<commit_message>
docs: align the application-teams deck with the current process
Slides and speaker notes now describe the starter and npm install setup,
local components without Core approval (build, then propose to share),
the generated CI workflow with build, unit and story tests, usage
reporting on by default, local token files, and Agenda and Open Sans in
pds-styles.

Co-Authored-By: Claude Opus 5.5 <noreply@anthropic.com>
</commit_message>
<xml_diff>
--- a/docs/Storybook for application teams.pptx
+++ b/docs/Storybook for application teams.pptx
@@ -605,7 +605,7 @@
           <a:p>
             <a:r>
               <a:rPr lang="en-US" dirty="0"/>
-              <a:t>KEY MESSAGE: four gates, one rule — nothing merges on trust. - Before commit: git hook check:commit — docs, contracts, tokens, lint, generated files saved. - Every Plectrum PR (ci.yml): intake-guard · build (drift audit, docs:check, contracts:check, lint, unit tests) · pack-smoke · storybook-tests (interaction + a11y) · storybook-packed · figma-plugin. - Chromatic visual tests: only when enabled — don't promise more. - Every token sync: three-way drift audit (blocking); report in the PR and in Figma. - Every app repo: plectrum check --profile ci — no hex, no px, no unknown --pds-*. - Release: same commit's CI, clean-app install, matching Storybook; "latest" never moves on a partial release. Source: Maintainer workflow — https://solidaris-danielbodigil.github.io/solidaris-plectrum/storybook/?path=/docs/docs-maintainer-workflow--docs</a:t>
+              <a:t>KEY MESSAGE: four gates, one rule — nothing merges on trust. - Before commit: git hook — check:commit in Plectrum, a fast token check in apps. - Every Plectrum PR (ci.yml): intake-guard · build (drift audit, docs:check, contracts:check, lint, unit tests) · pack-smoke · storybook-tests (interaction + a11y) · storybook-packed · figma-plugin. - Chromatic visual tests: only when enabled — don't promise more. - Every token sync: three-way drift audit (blocking); report in the PR and in Figma. - Every app repo: the generated workflow runs the Plectrum checks (no hex, px or unknown --pds-*), the build, unit tests, story + accessibility tests, and sends the usage report after a push to main. - Release: same commit's CI, clean-app install, matching Storybook; "latest" never moves on a partial release. Source: Maintainer workflow — https://solidaris-danielbodigil.github.io/solidaris-plectrum/storybook/latest/?path=/docs/docs-maintainer-workflow--docs</a:t>
             </a:r>
             <a:endParaRPr lang="en-US" dirty="0"/>
           </a:p>
@@ -693,7 +693,7 @@
           <a:p>
             <a:r>
               <a:rPr lang="en-US" dirty="0"/>
-              <a:t>KEY MESSAGE: a PR merges on evidence, not trust — tests and CI produce it, with or without AI. - Unit tests: Vitest — logic and coverage. - Story tests: every story renders; interaction (play) tests; axe accessibility checks. - Contracts + tokens: contracts:check (API), docs:check, generated files committed, token audit. - Package smoke: pack the libraries, install them in a clean throwaway app and build it — exactly what a team repo does (1 app = 1 repo). - Application CI: plectrum check --profile ci — compatibility, source scan, Candidate evidence. - Chromatic visual tests only when enabled — don't promise more. - Same gates for agent and human changes. Source: Maintainer workflow — https://solidaris-danielbodigil.github.io/solidaris-plectrum/storybook/?path=/docs/docs-maintainer-workflow--docs</a:t>
+              <a:t>KEY MESSAGE: a PR merges on evidence, not trust — tests and CI produce it, with or without AI. - Unit tests: Vitest — logic and coverage. - Story tests: every story renders; interaction (play) tests; axe accessibility checks. - Contracts + tokens: contracts:check (API), docs:check, generated files committed, token audit. - Package smoke: pack the libraries, install them in a clean app built from the starter, build it and run its stories — exactly what a team repo does. - Application CI: Plectrum checks, build, unit tests, story + accessibility tests. - Chromatic visual tests only when enabled — don't promise more. - Same gates for agent and human changes. Source: Maintainer workflow — https://solidaris-danielbodigil.github.io/solidaris-plectrum/storybook/latest/?path=/docs/docs-maintainer-workflow--docs</a:t>
             </a:r>
             <a:endParaRPr lang="en-US" dirty="0"/>
           </a:p>
@@ -781,7 +781,7 @@
           <a:p>
             <a:r>
               <a:rPr lang="en-US" dirty="0"/>
-              <a:t>KEY MESSAGE: every change lands through a reviewed PR; humans own the decisions. - Plectrum code (libs/): Code Owner review + design-system review. - Figma → repo: staging branch only; promotion needs a reviewed PR. - App candidates: candidate-submit opens a reviewed central PR; nothing becomes Core automatically. - Repo → Figma: a designer reviews proposals/{app}, then merges and publishes. - Apps: bumps arrive as Renovate / Dependabot PRs, gated by the app CI profile. - Releases: Changesets version PR; a maintainer runs the attended release. Source: Contribute · Maintainer workflow — https://solidaris-danielbodigil.github.io/solidaris-plectrum/storybook/?path=/docs/get-started-contribute--docs</a:t>
+              <a:t>KEY MESSAGE: every change lands through a reviewed PR; humans own the decisions. - Plectrum code (libs/): Code Owner review + design-system review. - Figma → repo: staging branch only; promotion needs a reviewed PR. - App candidates: candidate-submit opens a reviewed central PR; nothing becomes Core automatically. - Usage reports: app CI opens a central PR after a push to main; Core reviews it. - Repo → Figma: a designer reviews proposals/{app}, then merges and publishes. - Apps: bumps arrive as Renovate / Dependabot PRs, gated by the app's checks and tests. - Releases: Changesets version PR; a maintainer runs the attended release. Source: Contribute · Maintainer workflow — https://solidaris-danielbodigil.github.io/solidaris-plectrum/storybook/latest/?path=/docs/get-started-contribute--docs</a:t>
             </a:r>
             <a:endParaRPr lang="en-US" dirty="0"/>
           </a:p>
@@ -869,7 +869,7 @@
           <a:p>
             <a:r>
               <a:rPr lang="en-US" dirty="0"/>
-              <a:t>KEY MESSAGE: a typo is a PR; a gap is a proposal. - Small fix (typo, example, link): PR on Plectrum. - Gap (component, variant, token): proposal = a GitHub issue on Plectrum — the need, what you tried, a Figma link. Core records the decision on it. - Check themed PrimeNG and Core first — "a Candidate is not a core-team ticket". - Core records one decision: use-existing · app-specific · rejected · approved-candidate. - The toolkit only scaffolds and submits under approved-candidate. - Your team builds it → your team owns it. Nothing becomes Core automatically. - Already built it? Open the proposal anyway and attach it. Source: Contribute › Proposal decisions — https://solidaris-danielbodigil.github.io/solidaris-plectrum/storybook/?path=/docs/get-started-contribute--docs</a:t>
+              <a:t>KEY MESSAGE: build locally; propose to share. - Small fix (typo, example, link): PR on Plectrum. - Gap (component, variant, token): check themed PrimeNG and Core first; if nothing fits, the team builds it in its own repo — no approval needed. - To share it, open a proposal = a GitHub issue on Plectrum: the need, what you tried, a Figma link, a preview. - Core records one decision: use-existing · app-specific · rejected · approved-candidate. - Only approved-candidate lets the team submit the component to Core; the other decisions keep it local. - Your team builds it → your team owns it. Nothing becomes Core automatically. Source: Contribute › Proposal decisions — https://solidaris-danielbodigil.github.io/solidaris-plectrum/storybook/latest/?path=/docs/get-started-contribute--docs</a:t>
             </a:r>
             <a:endParaRPr lang="en-US" dirty="0"/>
           </a:p>
@@ -957,7 +957,7 @@
           <a:p>
             <a:r>
               <a:rPr lang="en-US" dirty="0"/>
-              <a:t>KEY MESSAGE: two routes to Core — from an app team or from the design team. - IMPORTANT: keep Core in the loop from the start of development — it avoids a Core bottleneck at integration, avoids building something that gets rejected or already exists, and you get guidance on reuse, naming and tokens. - Colours = actor: green app, blue Core, orange designer, grey release. - Every proposal is a GitHub issue in the central Plectrum repo — from an app team or a designer. - Step names simplified from Storybook: Discover → Propose, Approve → Decide, Implement → Build, Design return → Update Figma. - App route: the team proposes the gap → Core decides → the team builds in its repo and submits (candidate-submit) → Core integrates → designer updates Figma → release → the app adopts. - Until integration, the component stays the app's; nothing becomes Core automatically. - Candidates use feature names (c-affiliate-*), never Core names; the app CI profile still applies. - Design route: designer proposes from Custom components → Core decides and builds → release. Example: Profile header. - Corrections and Core work: a reviewed PR in the Plectrum repo. Source: Process and contracts — https://solidaris-danielbodigil.github.io/solidaris-plectrum/storybook/?path=/docs/docs-pipeline-contracts--docs</a:t>
+              <a:t>KEY MESSAGE: two routes to Core — from an app team or from the design team. - Propose early: Core can spot duplicates and give guidance on reuse, naming and tokens — and the team never waits to build locally. - Colours = actor: green app, blue Core, orange designer, grey release. - Every proposal is a GitHub issue in the central Plectrum repo — from an app team or a designer. - App route: the team builds in its repo → proposes the component → Core decides → the team submits (candidate-submit) → Core integrates → designer updates Figma → release → the app adopts. - Until integration, the component stays the app's; nothing becomes Core automatically. - Local components use feature names (c-affiliate-*), never Core names; the app checks still apply. - Design route: designer proposes from Custom components → Core decides and builds → release. Example: Profile header. - Corrections and Core work: a reviewed PR in the Plectrum repo. Source: Contribute — https://solidaris-danielbodigil.github.io/solidaris-plectrum/storybook/latest/?path=/docs/get-started-contribute--docs</a:t>
             </a:r>
             <a:endParaRPr lang="en-US" dirty="0"/>
           </a:p>
@@ -1045,7 +1045,7 @@
           <a:p>
             <a:r>
               <a:rPr lang="en-US" dirty="0"/>
-              <a:t>KEY MESSAGE: the whole process exists to stop teams redoing the same work — and everyone gains something. - Less duplicate maintenance (Core, app teams): one source, generated docs, no design-system code copied into apps. - Fewer local variants (app teams, Solidaris): PrimeNG → Core → proposal; one look across applications. - Earlier feedback (app teams, designers): stories, CI and review catch issues in the PR; sync results land in Figma. - Repeatable adoption (Solidaris, new teams): a new team = a registry entry + plectrum init; upgrades arrive as PRs. - Ask of every team: consume the packages, run the checks, return shared improvements through a GitHub issue. - Next step: one real pilot team walks the full path — proposal → decision → candidate → integration → release → adoption. Name who decides, builds and reviews. Source: Overview — https://solidaris-danielbodigil.github.io/solidaris-plectrum/storybook/?path=/docs/introduction--docs</a:t>
+              <a:t>KEY MESSAGE: the whole process exists to stop teams redoing the same work — and everyone gains something. - Less duplicate maintenance (Core, app teams): one source, generated docs, no design-system code copied into apps. - Fewer local variants (app teams, Solidaris): PrimeNG → Core → local build → proposal; one look across applications. - Earlier feedback (app teams, designers): stories, CI and review catch issues in the PR; sync results land in Figma. - Repeatable adoption (Solidaris, new teams): a new team = the starter + npm install; upgrades arrive as PRs; usage reports show who uses what. - Ask of every team: consume the packages, run the checks, return shared improvements through a GitHub issue. - Next step: one real pilot team walks the full path — local build → proposal → decision → submission → integration → release → adoption. Source: Overview — https://solidaris-danielbodigil.github.io/solidaris-plectrum/storybook/latest/?path=/docs/introduction--docs</a:t>
             </a:r>
             <a:endParaRPr lang="en-US" dirty="0"/>
           </a:p>
@@ -1133,7 +1133,7 @@
           <a:p>
             <a:r>
               <a:rPr lang="en-US" dirty="0"/>
-              <a:t>KEY MESSAGE: collect concrete blockers — let the teams speak first. - Sort questions: find · install · contribute · validate. - Note owners, pilot and missing access; command details → Storybook or a technical session. - Rebuild our app? No — install packages; build locally only after a decision. - Code to copy? No — consume a published version. - Can AI build a component? It prepares; people review. - Missing token? Describe the need, check existing roles, propose it; the value is reviewed. - Our own repo already? The isolated trial passed; a real repo is the pilot's goal. - Close: restate the pilot and access prerequisites.</a:t>
+              <a:t>KEY MESSAGE: collect concrete blockers — let the teams speak first. - Sort questions: find · install · contribute · validate. - Note owners, pilot and missing access; command details → Storybook or a technical session. - Rebuild our app? No — install packages; build local components whenever you need them. - Code to copy? No — consume a published version. - Can AI build a component? It prepares; people review. - Missing token? Use a local token file if only your app needs it; otherwise propose it. - Our own repo already? The starter and the consumer smoke test pass; a real repo is the pilot's goal. - Close: restate the pilot and access prerequisites.</a:t>
             </a:r>
             <a:endParaRPr lang="en-US" dirty="0"/>
           </a:p>
@@ -1221,7 +1221,7 @@
           <a:p>
             <a:r>
               <a:rPr lang="en-US" dirty="0"/>
-              <a:t>KEY MESSAGE: one shared system; each team owns its application. - Figma: shared visual decisions — designers own the values and the component designs. - Plectrum: shared code and contracts, published as Storybook + versioned packages; the Core team owns it. - Application teams: own repositories and screens; local Candidates only after a Core decision. - Apps install a version: nothing is copied, no Plectrum folder in the app. - Boundary: shared things change through Plectrum PRs and proposals; app code stays with the team. - Transition: "So how does a team actually use Plectrum? Through packages." Source: Overview — https://solidaris-danielbodigil.github.io/solidaris-plectrum/storybook/?path=/docs/introduction--docs</a:t>
+              <a:t>KEY MESSAGE: one shared system; each team owns its application. - Figma: shared visual decisions — designers own the values and the component designs. - Plectrum: shared code and contracts, published as Storybook + versioned packages; the Core team owns it. - Application teams: own repositories, screens and local components — they build them without waiting for Core. - Apps install a version: nothing is copied, no Plectrum folder in the app. - Boundary: shared things change through Plectrum PRs and proposals; app code stays with the team. - Transition: "So how does a team actually use Plectrum? Through packages." Source: Overview — https://solidaris-danielbodigil.github.io/solidaris-plectrum/storybook/latest/?path=/docs/introduction--docs</a:t>
             </a:r>
             <a:endParaRPr lang="en-US" dirty="0"/>
           </a:p>
@@ -1309,7 +1309,7 @@
           <a:p>
             <a:r>
               <a:rPr lang="en-US" dirty="0"/>
-              <a:t>KEY MESSAGE: teams don't copy Plectrum — they install it as versioned packages and keep their own repo. - 4 packages under @solidaris-danielbodigil on GitHub Packages (private; the team needs read access). - Runtime: pds-ui, pds-plectrum, pds-styles — version together. Toolkit: pds-devkit — dev dependency, own version. - Before init: Core registers the team, application and repo URL. - Initialize: plectrum init writes .plectrum/config.json, the Cursor / VS Code agents and a PR workflow running the CI profile. - Build: pds-styles on the include path + one @use in styles.scss; providePlectrum() in app.config themes PrimeNG. - Before you invent: themed PrimeNG → a Core pds-* component → a proposal. - App rules: CSS is the API (var(--pds-*), o- / c- / u- classes); no token copies; no silent duplicates. - Upgrade: Renovate / Dependabot PRs → plectrum update → validate. What's new lists breaking changes. - Today main is a development preview: a pilot installs packed tarballs until the release is published. Source: Build with Plectrum — https://solidaris-danielbodigil.github.io/solidaris-plectrum/storybook/?path=/docs/get-started-use-plectrum-in-an-app--docs</a:t>
+              <a:t>KEY MESSAGE: teams don't copy Plectrum — they install it as versioned packages and keep their own repo. - 4 packages under @solidaris-danielbodigil on GitHub Packages (private; the team needs read access). - Runtime: pds-ui, pds-plectrum, pds-styles (styles, tokens, Agenda and Open Sans fonts) — version together. Toolkit: pds-devkit — dev dependency, own version. - Install: copy the Plectrum starter, set the team and application IDs in package.json, run npm install. - Set up: npm install runs plectrum bootstrap — empty local ITCSS layers, styles and fonts wired, local Storybook, unit and story tests, a pre-commit hook, agents and a CI workflow. Commit the generated files. - Build: providePlectrum() is already in app.config; local styles go in src/styles/06-components. - Validate: the generated workflow runs the checks, the build, unit tests and story + accessibility tests on every PR. - Adopt: CI sends a usage report to Core once the team is registered and the PLECTRUM_ADOPTION_TOKEN secret is set; the local Storybook page Plectrum/Setup shows what is missing. - Upgrade: Renovate / Dependabot PRs → plectrum update → checks. What's new lists the changes. Source: Build with Plectrum — https://solidaris-danielbodigil.github.io/solidaris-plectrum/storybook/latest/?path=/docs/get-started-use-plectrum-in-an-app--docs</a:t>
             </a:r>
             <a:endParaRPr lang="en-US" dirty="0"/>
           </a:p>
@@ -1573,7 +1573,7 @@
           <a:p>
             <a:r>
               <a:rPr lang="en-US" dirty="0"/>
-              <a:t>KEY MESSAGE: one loop — tokens flow down to apps and back up to Figma; every direction ends in a human merge. - Diagram: Storybook's "Pipeline architecture". Orange = Figma, blue = repo, green = app; dashed = manual. - 1: plugin sync → staging branch design-tokens/sync → reviewed PR into tokens.json. - 2: tokens:build → CSS + Storybook manifest. 3–4: packages published → Renovate / Dependabot bump the apps. - 5: an app team PR adds code-owned --pds-* tokens in Plectrum. - 6–7: tokens:propose → agent (Figma MCP) or tokens plugin → proposals/{app} → a designer merges and publishes. - Every sync: three-way drift audit (Figma, preset, SCSS); report in the PR and as a Figma comment. - Last sync: 25 Sept 2026 — 2,849 / 2,849 tokens resolve, audit passed. Source: Token pipeline › Architecture · Figma sync — https://solidaris-danielbodigil.github.io/solidaris-plectrum/storybook/?path=/docs/docs-token-pipeline--docs</a:t>
+              <a:t>KEY MESSAGE: one loop — tokens flow down to apps and back up to Figma; every direction ends in a human merge. - Diagram: Storybook's "Pipeline architecture". Orange = Figma, blue = repo, green = app; dashed = manual. - 1: plugin sync → staging branch design-tokens/sync → reviewed PR into tokens.json. - 2: tokens:build → CSS + Storybook manifest. 3–4: packages released → Renovate / Dependabot bump the apps. - 5: a token only one app needs stays in that app (local token file); a token other teams could use is proposed, and Core adds it to 01-settings. - 6–7: tokens:propose → agent (Figma MCP) or tokens plugin → proposals/{app} → a designer merges and publishes. - Every sync: three-way drift audit (Figma, preset, SCSS); report in the PR and as a Figma comment. Source: Token pipeline › Architecture · Figma sync — https://solidaris-danielbodigil.github.io/solidaris-plectrum/storybook/latest/?path=/docs/docs-token-pipeline--docs</a:t>
             </a:r>
             <a:endParaRPr lang="en-US" dirty="0"/>
           </a:p>
@@ -1661,7 +1661,7 @@
           <a:p>
             <a:r>
               <a:rPr lang="en-US" dirty="0"/>
-              <a:t>KEY MESSAGE: agents read typed contracts, not the whole repo — Contract-Driven Development (CDD). - One flow = Storybook's "Contract layers" (index → metadata → protocols → libs/ui) + the component-creation pre-flight (PrimeNG, Figma, index, Storybook MCP). - index.json: generated map — what exists, where, status, owner. - {name}.metadata.ts: how and why to use it — use cases, anti-patterns, tokens, a11y, AI hints. - protocols/: decision trees for create, query, audit. - Steps 1–4 find what exists; steps 5–7 only run when something is really missing. - "Starter files" (Storybook says "scaffold"): one command creates the Angular files, .metadata.ts, story stub and styles — only after Core approves. - Example prompt: the pre-flight finds PrimeNG DatePicker (range mode) already covers the need → no new component, no proposal. The Storybook's own example (status banner) is on slide 8. - Humans still own review, Storybook, CSS and Figma publication. - By hand: covered on slide 9 (No AI?) — same scripts, tests, CI gates and reviews, just slower. Source: AI strategy — https://solidaris-danielbodigil.github.io/solidaris-plectrum/storybook/?path=/docs/docs-ai-strategy--docs</a:t>
+              <a:t>KEY MESSAGE: agents read typed contracts, not the whole repo — Contract-Driven Development (CDD). - One flow = Storybook's "Contract layers" (index → metadata → protocols → component) + the pre-flight (PrimeNG, Figma, index, Storybook MCP). - index.json: generated map — what exists, where, status, owner. - {name}.metadata.ts: how and why to use it — use cases, anti-patterns, tokens, a11y, AI hints. - protocols/: decision trees for create, query, audit. - Steps 1–4 find what exists; steps 5–7 only run when something is really missing. - In an app, the scaffold creates the component, story, unit test, metadata and styles — no Core approval needed. In Plectrum, a Core component starts after Core's decision. - Example prompt: the pre-flight finds PrimeNG DatePicker (range mode) already covers the need → no new component. - Humans still own review, Storybook, CSS and Figma publication. - By hand: slide 9 — same scripts, tests, CI gates and reviews. Source: AI strategy — https://solidaris-danielbodigil.github.io/solidaris-plectrum/storybook/latest/?path=/docs/docs-ai-strategy--docs</a:t>
             </a:r>
             <a:endParaRPr lang="en-US" dirty="0"/>
           </a:p>
@@ -1749,7 +1749,7 @@
           <a:p>
             <a:r>
               <a:rPr lang="en-US" dirty="0"/>
-              <a:t>KEY MESSAGE: the agent prepares, checks verify, people decide. - /plectrum is the only user-facing agent; it coordinates 6 specialists. - UX Researcher: Figma inspection, design brief (read-only). - UX Engineer: SCSS tokens, styles, stories. - Frontend Dev: Angular implementation, a11y, PrimeNG wiring. - Tester: unit tests, story coverage, WCAG 2.1 AA. - Token Auditor + Architect: drift, naming, boundaries (read-only). - Written once in .ai/agents/; plectrum init installs them in each app repo. - Every route still needs a proposal, a Core decision, a review and a human Figma merge. Source: AI strategy › Subagents — https://solidaris-danielbodigil.github.io/solidaris-plectrum/storybook/?path=/docs/docs-ai-strategy--docs</a:t>
+              <a:t>KEY MESSAGE: the agent prepares, checks verify, people decide. - /plectrum is the only user-facing agent; it coordinates 6 specialists. - UX Researcher: Figma inspection, design brief (read-only). - UX Engineer: SCSS tokens, styles, stories. - Frontend Dev: Angular implementation, a11y, PrimeNG wiring. - Tester: unit tests, story coverage, WCAG 2.1 AA. - Token Auditor + Architect: drift, naming, boundaries (read-only). - Written once in .ai/agents/; npm install (plectrum bootstrap) generates them in each app repo. - Local components need no Core decision; sharing through Core still needs a proposal, a decision, a review and a release. Source: AI strategy › Subagents — https://solidaris-danielbodigil.github.io/solidaris-plectrum/storybook/latest/?path=/docs/docs-ai-strategy--docs</a:t>
             </a:r>
             <a:endParaRPr lang="en-US" dirty="0"/>
           </a:p>
@@ -1837,7 +1837,7 @@
           <a:p>
             <a:r>
               <a:rPr lang="en-US" dirty="0"/>
-              <a:t>KEY MESSAGE: no AI? Nothing lost — same scripts, same CI, same reviews. - Storybook: "It is a choice, not a requirement." - Find — agent: PrimeNG MCP → index.json → Storybook MCP (same order as the pre-flight on slide 7). - Find — by hand: check themed PrimeNG first, then Find a component or plectrum catalogue (offline). - Create: plectrum scaffold (app repo, after approval) or pds:component (Plectrum repo). - Check: plectrum check --profile ci. - Figma to tokens: an agent can read variables via Figma MCP, or the designer runs the plugin sync; either way the CI drift audit runs and a developer merges the PR. - Tokens to Figma: tokens:propose + the Plectrum tokens plugin. - Figma components: a designer draws them; merge and publish stay human. - CI runs regardless — agent and human changes alike. Source: AI strategy · Token pipeline › Commands — https://solidaris-danielbodigil.github.io/solidaris-plectrum/storybook/?path=/docs/docs-ai-strategy--docs</a:t>
+              <a:t>KEY MESSAGE: no AI? Nothing lost — same scripts, same CI, same reviews. - Find — agent: PrimeNG MCP → index.json → Storybook MCP (same order as the pre-flight on slide 7). - Find — by hand: themed PrimeNG first, then Find a component or plectrum catalogue (offline). - Create: npm run pds:component in an app (no approval needed), pds:component in the Plectrum repo. - Check: npm run pds:check:ci, then build and tests. - Figma to tokens: an agent reads variables via Figma MCP, or the designer runs the plugin sync; the CI drift audit runs and a developer merges the PR. - Tokens to Figma: tokens:propose + the Plectrum tokens plugin. - Figma components: a designer draws them; merge and publish stay human. - CI runs regardless — agent and human changes alike. Source: AI strategy · Token pipeline › Commands — https://solidaris-danielbodigil.github.io/solidaris-plectrum/storybook/latest/?path=/docs/docs-ai-strategy--docs</a:t>
             </a:r>
             <a:endParaRPr lang="en-US" dirty="0"/>
           </a:p>
@@ -3486,7 +3486,7 @@
                 <a:ea typeface="Nunito Sans" pitchFamily="34" charset="-122"/>
                 <a:cs typeface="Nunito Sans" pitchFamily="34" charset="-120"/>
               </a:rPr>
-              <a:t>The CI profile</a:t>
+              <a:t>The generated workflow</a:t>
             </a:r>
             <a:endParaRPr lang="en-US" sz="1400" dirty="0"/>
           </a:p>
@@ -3531,7 +3531,7 @@
                 <a:ea typeface="Nunito Sans" pitchFamily="34" charset="-122"/>
                 <a:cs typeface="Nunito Sans" pitchFamily="34" charset="-120"/>
               </a:rPr>
-              <a:t>no hex, px or unknown token</a:t>
+              <a:t>token and contract checks</a:t>
             </a:r>
             <a:endParaRPr lang="en-US" sz="1200" dirty="0"/>
           </a:p>
@@ -3552,7 +3552,7 @@
                 <a:ea typeface="Nunito Sans" pitchFamily="34" charset="-122"/>
                 <a:cs typeface="Nunito Sans" pitchFamily="34" charset="-120"/>
               </a:rPr>
-              <a:t>source scan</a:t>
+              <a:t>build + unit tests</a:t>
             </a:r>
             <a:endParaRPr lang="en-US" sz="1200" dirty="0"/>
           </a:p>
@@ -3573,7 +3573,7 @@
                 <a:ea typeface="Nunito Sans" pitchFamily="34" charset="-122"/>
                 <a:cs typeface="Nunito Sans" pitchFamily="34" charset="-120"/>
               </a:rPr>
-              <a:t>packages and adapters</a:t>
+              <a:t>stories + accessibility</a:t>
             </a:r>
             <a:endParaRPr lang="en-US" sz="1200" dirty="0"/>
           </a:p>
@@ -3594,7 +3594,7 @@
                 <a:ea typeface="Nunito Sans" pitchFamily="34" charset="-122"/>
                 <a:cs typeface="Nunito Sans" pitchFamily="34" charset="-120"/>
               </a:rPr>
-              <a:t>candidate stories, evidence</a:t>
+              <a:t>usage report to Core</a:t>
             </a:r>
             <a:endParaRPr lang="en-US" sz="1200" dirty="0"/>
           </a:p>
@@ -4450,7 +4450,7 @@
                 <a:ea typeface="Nunito Sans" pitchFamily="34" charset="-122"/>
                 <a:cs typeface="Nunito Sans" pitchFamily="34" charset="-120"/>
               </a:rPr>
-              <a:t>Compatibility, source + Candidate evidence</a:t>
+              <a:t>Checks, build, unit + story tests</a:t>
             </a:r>
             <a:endParaRPr lang="en-US" sz="1600" dirty="0"/>
           </a:p>
@@ -5946,7 +5946,7 @@
                           <a:ea typeface="Nunito Sans" pitchFamily="34" charset="-122"/>
                           <a:cs typeface="Nunito Sans" pitchFamily="34" charset="-120"/>
                         </a:rPr>
-                        <a:t>An adoption report</a:t>
+                        <a:t>A usage report</a:t>
                       </a:r>
                       <a:endParaRPr lang="en-US" sz="1200" dirty="0">
                         <a:latin typeface="Nunito Sans" charset="0"/>
@@ -6014,7 +6014,7 @@
                           <a:ea typeface="Nunito Sans" pitchFamily="34" charset="-122"/>
                           <a:cs typeface="Nunito Sans" pitchFamily="34" charset="-120"/>
                         </a:rPr>
-                        <a:t>central PR</a:t>
+                        <a:t>central PR from app CI</a:t>
                       </a:r>
                       <a:endParaRPr lang="en-US" sz="1200" dirty="0">
                         <a:latin typeface="Nunito Sans" charset="0"/>
@@ -6294,7 +6294,7 @@
                           <a:ea typeface="Nunito Sans" pitchFamily="34" charset="-122"/>
                           <a:cs typeface="Nunito Sans" pitchFamily="34" charset="-120"/>
                         </a:rPr>
-                        <a:t>your team, with the CI profile</a:t>
+                        <a:t>your team, with its checks and tests</a:t>
                       </a:r>
                       <a:endParaRPr lang="en-US" sz="1200" dirty="0">
                         <a:latin typeface="Nunito Sans" charset="0"/>
@@ -6758,7 +6758,7 @@
                 <a:ea typeface="Alegreya Sans" pitchFamily="34" charset="-122"/>
                 <a:cs typeface="Alegreya Sans" pitchFamily="34" charset="-120"/>
               </a:rPr>
-              <a:t>CONTRIBUTING — PROPOSE BEFORE CODE</a:t>
+              <a:t>CONTRIBUTING — BUILD LOCALLY, PROPOSE TO SHARE</a:t>
             </a:r>
             <a:endParaRPr lang="en-US" sz="1300" dirty="0"/>
           </a:p>
@@ -7590,7 +7590,7 @@
                 <a:ea typeface="Nunito Sans" pitchFamily="34" charset="-122"/>
                 <a:cs typeface="Nunito Sans" pitchFamily="34" charset="-120"/>
               </a:rPr>
-              <a:t>no candidate</a:t>
+              <a:t>not shared; build locally if needed</a:t>
             </a:r>
             <a:endParaRPr lang="en-US" sz="1200" dirty="0"/>
           </a:p>
@@ -8189,7 +8189,7 @@
                 <a:ea typeface="Alegreya Sans" pitchFamily="34" charset="-122"/>
                 <a:cs typeface="Alegreya Sans" pitchFamily="34" charset="-120"/>
               </a:rPr>
-              <a:t>App team → proposal → decision → Core release</a:t>
+              <a:t>App team → build → proposal → Core release</a:t>
             </a:r>
             <a:endParaRPr lang="en-US" sz="3070" dirty="0"/>
           </a:p>
@@ -8381,7 +8381,7 @@
                 <a:ea typeface="Nunito Sans" pitchFamily="34" charset="-122"/>
                 <a:cs typeface="Nunito Sans" pitchFamily="34" charset="-120"/>
               </a:rPr>
-              <a:t>Propose </a:t>
+              <a:t>Build + propose </a:t>
             </a:r>
             <a:r>
               <a:rPr lang="en-US" sz="1300" b="1" dirty="0">
@@ -8436,7 +8436,7 @@
                 <a:ea typeface="Nunito Sans" pitchFamily="34" charset="-122"/>
                 <a:cs typeface="Nunito Sans" pitchFamily="34" charset="-120"/>
               </a:rPr>
-              <a:t>GitHub issue: the need, what you tried, a Figma link</a:t>
+              <a:t>No approval to build; open an issue to share it</a:t>
             </a:r>
             <a:endParaRPr lang="en-US" sz="1200" dirty="0"/>
           </a:p>
@@ -8765,7 +8765,7 @@
                 <a:ea typeface="Nunito Sans" pitchFamily="34" charset="-122"/>
                 <a:cs typeface="Nunito Sans" pitchFamily="34" charset="-120"/>
               </a:rPr>
-              <a:t>Build </a:t>
+              <a:t>Complete </a:t>
             </a:r>
             <a:r>
               <a:rPr lang="en-US" sz="1300" b="1" dirty="0">
@@ -8820,7 +8820,7 @@
                 <a:ea typeface="Nunito Sans" pitchFamily="34" charset="-122"/>
                 <a:cs typeface="Nunito Sans" pitchFamily="34" charset="-120"/>
               </a:rPr>
-              <a:t>In your repo: starter files, stories, metadata, tests</a:t>
+              <a:t>Stories, tests, evidence and a preview</a:t>
             </a:r>
             <a:endParaRPr lang="en-US" sz="1200" dirty="0"/>
           </a:p>
@@ -10657,7 +10657,7 @@
                 <a:ea typeface="Nunito Sans" pitchFamily="34" charset="-122"/>
                 <a:cs typeface="Nunito Sans" pitchFamily="34" charset="-120"/>
               </a:rPr>
-              <a:t> bring the Core team in early — no bottleneck, no wasted work, better guidance.</a:t>
+              <a:t> propose early so Core can spot duplicates — you never wait to build locally.</a:t>
             </a:r>
             <a:endParaRPr lang="en-US" sz="1400" dirty="0"/>
           </a:p>
@@ -13515,7 +13515,7 @@
                 <a:ea typeface="Nunito Sans" pitchFamily="34" charset="-122"/>
                 <a:cs typeface="Nunito Sans" pitchFamily="34" charset="-120"/>
               </a:rPr>
-              <a:t>ITCSS styles and --pds-* tokens</a:t>
+              <a:t>ITCSS styles, --pds-* tokens, fonts</a:t>
             </a:r>
             <a:endParaRPr lang="en-US" sz="1200" dirty="0"/>
           </a:p>
@@ -13625,7 +13625,7 @@
                 <a:ea typeface="Nunito Sans" pitchFamily="34" charset="-122"/>
                 <a:cs typeface="Nunito Sans" pitchFamily="34" charset="-120"/>
               </a:rPr>
-              <a:t>Team toolkit: plectrum CLI, agents, contracts</a:t>
+              <a:t>Team toolkit: CLI, app setup, agents, checks</a:t>
             </a:r>
             <a:endParaRPr lang="en-US" sz="1200" dirty="0"/>
           </a:p>
@@ -13861,7 +13861,7 @@
                 <a:ea typeface="Nunito Sans" pitchFamily="34" charset="-122"/>
                 <a:cs typeface="Nunito Sans" pitchFamily="34" charset="-120"/>
               </a:rPr>
-              <a:t> — the four packages from GitHub Packages</a:t>
+              <a:t> — copy the starter, then npm install</a:t>
             </a:r>
             <a:endParaRPr lang="en-US" sz="1300" dirty="0"/>
           </a:p>
@@ -13998,7 +13998,7 @@
                 <a:ea typeface="Nunito Sans" pitchFamily="34" charset="-122"/>
                 <a:cs typeface="Nunito Sans" pitchFamily="34" charset="-120"/>
               </a:rPr>
-              <a:t>Initialize</a:t>
+              <a:t>Set up</a:t>
             </a:r>
             <a:r>
               <a:rPr lang="en-US" sz="1300" dirty="0">
@@ -14009,7 +14009,7 @@
                 <a:ea typeface="Nunito Sans" pitchFamily="34" charset="-122"/>
                 <a:cs typeface="Nunito Sans" pitchFamily="34" charset="-120"/>
               </a:rPr>
-              <a:t> — plectrum init: config, agents, CI workflow</a:t>
+              <a:t> — styles, Storybook, tests, hook and CI generated</a:t>
             </a:r>
             <a:endParaRPr lang="en-US" sz="1300" dirty="0"/>
           </a:p>
@@ -14157,7 +14157,7 @@
                 <a:ea typeface="Nunito Sans" pitchFamily="34" charset="-122"/>
                 <a:cs typeface="Nunito Sans" pitchFamily="34" charset="-120"/>
               </a:rPr>
-              <a:t> — one @use + providePlectrum() → themed screens</a:t>
+              <a:t> — theme, styles and fonts already wired</a:t>
             </a:r>
             <a:endParaRPr lang="en-US" sz="1300" dirty="0"/>
           </a:p>
@@ -14305,7 +14305,7 @@
                 <a:ea typeface="Nunito Sans" pitchFamily="34" charset="-122"/>
                 <a:cs typeface="Nunito Sans" pitchFamily="34" charset="-120"/>
               </a:rPr>
-              <a:t> — plectrum check --profile ci on every PR</a:t>
+              <a:t> — checks, build and tests on every PR</a:t>
             </a:r>
             <a:endParaRPr lang="en-US" sz="1300" dirty="0"/>
           </a:p>
@@ -14453,7 +14453,7 @@
                 <a:ea typeface="Nunito Sans" pitchFamily="34" charset="-122"/>
                 <a:cs typeface="Nunito Sans" pitchFamily="34" charset="-120"/>
               </a:rPr>
-              <a:t> — report installed versions and component usage</a:t>
+              <a:t> — CI reports component usage to Core</a:t>
             </a:r>
             <a:endParaRPr lang="en-US" sz="1300" dirty="0"/>
           </a:p>
@@ -19765,7 +19765,7 @@
                 <a:ea typeface="Nunito Sans" pitchFamily="34" charset="-122"/>
                 <a:cs typeface="Nunito Sans" pitchFamily="34" charset="-120"/>
               </a:rPr>
-              <a:t>libs/ui component</a:t>
+              <a:t>your component</a:t>
             </a:r>
             <a:endParaRPr lang="en-US" sz="1300" dirty="0"/>
           </a:p>
@@ -19809,7 +19809,7 @@
                 <a:ea typeface="Nunito Sans" pitchFamily="34" charset="-122"/>
                 <a:cs typeface="Nunito Sans" pitchFamily="34" charset="-120"/>
               </a:rPr>
-              <a:t>starter files, generated once Core approves</a:t>
+              <a:t>scaffolded locally, no approval needed</a:t>
             </a:r>
             <a:endParaRPr lang="en-US" sz="1200" dirty="0"/>
           </a:p>
@@ -20434,7 +20434,7 @@
                 <a:ea typeface="Nunito Sans" pitchFamily="34" charset="-122"/>
                 <a:cs typeface="Nunito Sans" pitchFamily="34" charset="-120"/>
               </a:rPr>
-              <a:t>Cursor and VS Code / Copilot, generated by plectrum init.</a:t>
+              <a:t>Cursor and VS Code / Copilot, generated at npm install.</a:t>
             </a:r>
             <a:endParaRPr lang="en-US" sz="1200" dirty="0"/>
           </a:p>
@@ -23058,7 +23058,7 @@
                 <a:ea typeface="Alegreya Sans" pitchFamily="34" charset="-122"/>
                 <a:cs typeface="Alegreya Sans" pitchFamily="34" charset="-120"/>
               </a:rPr>
-              <a:t>“You can still do any of these steps by hand. It is a choice, not a requirement.”</a:t>
+              <a:t>“The agent usually runs these steps; you can do each one by hand.”</a:t>
             </a:r>
             <a:endParaRPr lang="en-US" sz="1600" dirty="0"/>
           </a:p>

</xml_diff>

<commit_message>
docs: show /plectrum as the first reviewer in figures and the deck
The contribution journey's discover step and the Overview "Find the next
piece" step now start with asking /plectrum and talking early to a
designer for new UX. In the deck, the /plectrum card (slide 8) and the
contribution banner (slide 14) say the same, and the speaker notes of
slides 8, 13 and 14 explain the advisory role.

Co-Authored-By: Claude Opus 5.5 <noreply@anthropic.com>
(cherry picked from commit c461976e2782aa4c0d7935992c6a088fa797c95a)
</commit_message>
<xml_diff>
--- a/docs/Storybook for application teams.pptx
+++ b/docs/Storybook for application teams.pptx
@@ -869,7 +869,7 @@
           <a:p>
             <a:r>
               <a:rPr lang="en-US" dirty="0"/>
-              <a:t>KEY MESSAGE: build locally; propose to share. - Small fix (typo, example, link): PR on Plectrum. - Gap (component, variant, token): check themed PrimeNG and Core first; if nothing fits, the team builds it in its own repo — no approval needed. - To share it, open a proposal = a GitHub issue on Plectrum: the need, what you tried, a Figma link, a preview. - Core records one decision: use-existing · app-specific · rejected · approved-candidate. - Only approved-candidate lets the team submit the component to Core; the other decisions keep it local. - Your team builds it → your team owns it. Nothing becomes Core automatically. Source: Contribute › Proposal decisions — https://solidaris-danielbodigil.github.io/solidaris-plectrum/storybook/latest/?path=/docs/get-started-contribute--docs</a:t>
+              <a:t>KEY MESSAGE: build locally; propose to share. - Small fix (typo, example, link): PR on Plectrum. - Gap (component, variant, token): check themed PrimeNG and Core first; if nothing fits, the team builds it in its own repo — no approval needed. - To share it, open a proposal = a GitHub issue on Plectrum: the need, what you tried, a Figma link, a preview. - Core records one decision: use-existing · app-specific · rejected · approved-candidate. - Only approved-candidate lets the team submit the component to Core; the other decisions keep it local. - Your team builds it → your team owns it. Nothing becomes Core automatically. - Before building, ask /plectrum: it often finds that an existing component or composition already does the job. For new UX, talk early to the core team or a designer — advice, not an approval step. Source: Contribute › Proposal decisions — https://solidaris-danielbodigil.github.io/solidaris-plectrum/storybook/latest/?path=/docs/get-started-contribute--docs</a:t>
             </a:r>
             <a:endParaRPr lang="en-US" dirty="0"/>
           </a:p>
@@ -957,7 +957,7 @@
           <a:p>
             <a:r>
               <a:rPr lang="en-US" dirty="0"/>
-              <a:t>KEY MESSAGE: two routes to Core — from an app team or from the design team. - Propose early: Core can spot duplicates and give guidance on reuse, naming and tokens — and the team never waits to build locally. - Colours = actor: green app, blue Core, orange designer, grey release. - Every proposal is a GitHub issue in the central Plectrum repo — from an app team or a designer. - App route: the team builds in its repo → proposes the component → Core decides → the team submits (candidate-submit) → Core integrates → designer updates Figma → release → the app adopts. - Until integration, the component stays the app's; nothing becomes Core automatically. - Local components use feature names (c-affiliate-*), never Core names; the app checks still apply. - Design route: designer proposes from Custom components → Core decides and builds → release. Example: Profile header. - Corrections and Core work: a reviewed PR in the Plectrum repo. Source: Contribute — https://solidaris-danielbodigil.github.io/solidaris-plectrum/storybook/latest/?path=/docs/get-started-contribute--docs</a:t>
+              <a:t>KEY MESSAGE: two routes to Core — from an app team or from the design team. - Propose early: Core can spot duplicates and give guidance on reuse, naming and tokens — and the team never waits to build locally. - Ask /plectrum first: it checks reuse and helps with layout and UX; designers still join the loop early for new UX. - Colours = actor: green app, blue Core, orange designer, grey release. - Every proposal is a GitHub issue in the central Plectrum repo — from an app team or a designer. - App route: the team builds in its repo → proposes the component → Core decides → the team submits (candidate-submit) → Core integrates → designer updates Figma → release → the app adopts. - Until integration, the component stays the app's; nothing becomes Core automatically. - Local components use feature names (c-affiliate-*), never Core names; the app checks still apply. - Design route: designer proposes from Custom components → Core decides and builds → release. Example: Profile header. - Corrections and Core work: a reviewed PR in the Plectrum repo. Source: Contribute — https://solidaris-danielbodigil.github.io/solidaris-plectrum/storybook/latest/?path=/docs/get-started-contribute--docs</a:t>
             </a:r>
             <a:endParaRPr lang="en-US" dirty="0"/>
           </a:p>
@@ -1749,7 +1749,7 @@
           <a:p>
             <a:r>
               <a:rPr lang="en-US" dirty="0"/>
-              <a:t>KEY MESSAGE: the agent prepares, checks verify, people decide. - /plectrum is the only user-facing agent; it coordinates 6 specialists. - UX Researcher: Figma inspection, design brief (read-only). - UX Engineer: SCSS tokens, styles, stories. - Frontend Dev: Angular implementation, a11y, PrimeNG wiring. - Tester: unit tests, story coverage, WCAG 2.1 AA. - Token Auditor + Architect: drift, naming, boundaries (read-only). - Written once in .ai/agents/; npm install (plectrum bootstrap) generates them in each app repo. - Local components need no Core decision; sharing through Core still needs a proposal, a decision, a review and a release. Source: AI strategy › Subagents — https://solidaris-danielbodigil.github.io/solidaris-plectrum/storybook/latest/?path=/docs/docs-ai-strategy--docs</a:t>
+              <a:t>KEY MESSAGE: the agent prepares, checks verify, people decide. - /plectrum is the only user-facing agent; it coordinates 6 specialists. - UX Researcher: Figma inspection, design brief (read-only). - UX Engineer: SCSS tokens, styles, stories. - Frontend Dev: Angular implementation, a11y, PrimeNG wiring. - Tester: unit tests, story coverage, WCAG 2.1 AA. - Token Auditor + Architect: drift, naming, boundaries (read-only). - Written once in .ai/agents/; npm install (plectrum bootstrap) generates them in each app repo. - Local components need no Core decision; sharing through Core still needs a proposal, a decision, a review and a release. - In an application, /plectrum is the team's first reviewer: before anything is built it checks PrimeNG and the catalogue, says when an existing component or composition already covers the need, and answers layout and UX questions. It names what a designer should decide and recommends showing new UX early to the core team or a designer — it does not replace them. Source: AI strategy › Subagents — https://solidaris-danielbodigil.github.io/solidaris-plectrum/storybook/latest/?path=/docs/docs-ai-strategy--docs</a:t>
             </a:r>
             <a:endParaRPr lang="en-US" dirty="0"/>
           </a:p>
@@ -10657,7 +10657,7 @@
                 <a:ea typeface="Nunito Sans" pitchFamily="34" charset="-122"/>
                 <a:cs typeface="Nunito Sans" pitchFamily="34" charset="-120"/>
               </a:rPr>
-              <a:t> propose early so Core can spot duplicates — you never wait to build locally.</a:t>
+              <a:t> ask /plectrum first, and show new UX early to Core or a designer.</a:t>
             </a:r>
             <a:endParaRPr lang="en-US" sz="1400" dirty="0"/>
           </a:p>
@@ -20390,7 +20390,7 @@
                 <a:ea typeface="Nunito Sans" pitchFamily="34" charset="-122"/>
                 <a:cs typeface="Nunito Sans" pitchFamily="34" charset="-120"/>
               </a:rPr>
-              <a:t>The only agent you talk to. It delegates to the specialists.</a:t>
+              <a:t>Your first reviewer: reuse, layout, UX. It delegates to the specialists.</a:t>
             </a:r>
             <a:endParaRPr lang="en-US" sz="1200" dirty="0"/>
           </a:p>

</xml_diff>

<commit_message>
docs: describe the local-component sharing loop in Storybook and the deck
Contribute gets a "sharing loop" figure (build locally, CI reports,
Core spots what to share, Core contacts the team) and the roles now say
Core reviews local components and teams estimate reuse. Overview and
the agent callout mention that local components reach Core and that the
agent checks other teams' components.

Deck: slide 3 (CI reports usage and local components), slide 13
(approved-candidate: build, then submit), slide 15 (local components
seen by Core) and speaker notes 3, 13, 14 and 15.

Co-Authored-By: Claude Opus 5.5 <noreply@anthropic.com>
</commit_message>
<xml_diff>
--- a/docs/Storybook for application teams.pptx
+++ b/docs/Storybook for application teams.pptx
@@ -869,7 +869,7 @@
           <a:p>
             <a:r>
               <a:rPr lang="en-US" dirty="0"/>
-              <a:t>KEY MESSAGE: build locally; propose to share. - Small fix (typo, example, link): PR on Plectrum. - Gap (component, variant, token): check themed PrimeNG and Core first; if nothing fits, the team builds it in its own repo — no approval needed. - To share it, open a proposal = a GitHub issue on Plectrum: the need, what you tried, a Figma link, a preview. - Core records one decision: use-existing · app-specific · rejected · approved-candidate. - Only approved-candidate lets the team submit the component to Core; the other decisions keep it local. - Your team builds it → your team owns it. Nothing becomes Core automatically. - Before building, ask /plectrum: it often finds that an existing component or composition already does the job. For new UX, talk early to the core team or a designer — advice, not an approval step. Source: Contribute › Proposal decisions — https://solidaris-danielbodigil.github.io/solidaris-plectrum/storybook/latest/?path=/docs/get-started-contribute--docs</a:t>
+              <a:t>KEY MESSAGE: build locally; propose to share. - Small fix (typo, example, link): PR on Plectrum. - Gap (component, variant, token): check themed PrimeNG and Core first; if nothing fits, the team builds it in its own repo — no approval needed. - To share it, open a proposal = a GitHub issue on Plectrum: the need, what you tried, a Figma link, a preview. - Core records one decision: use-existing · app-specific · rejected · approved-candidate. - Only approved-candidate lets the team submit the component to Core; the other decisions keep it local. - Your team builds it → your team owns it. Nothing becomes Core automatically. - Before building, ask /plectrum: it often finds that an existing component or composition already does the job. For new UX, talk early to the core team or a designer — advice, not an approval step. - Teams do not have to spot what is worth sharing: each local component's evidence checklist has a Reuse potential line (none / possible / likely), the usage report sends it to Core, and Core reviews the Local scope of Find a component to pick what to share. Source: Contribute › Proposal decisions — https://solidaris-danielbodigil.github.io/solidaris-plectrum/storybook/latest/?path=/docs/get-started-contribute--docs</a:t>
             </a:r>
             <a:endParaRPr lang="en-US" dirty="0"/>
           </a:p>
@@ -957,7 +957,7 @@
           <a:p>
             <a:r>
               <a:rPr lang="en-US" dirty="0"/>
-              <a:t>KEY MESSAGE: two routes to Core — from an app team or from the design team. - Propose early: Core can spot duplicates and give guidance on reuse, naming and tokens — and the team never waits to build locally. - Ask /plectrum first: it checks reuse and helps with layout and UX; designers still join the loop early for new UX. - Colours = actor: green app, blue Core, orange designer, grey release. - Every proposal is a GitHub issue in the central Plectrum repo — from an app team or a designer. - App route: the team builds in its repo → proposes the component → Core decides → the team submits (candidate-submit) → Core integrates → designer updates Figma → release → the app adopts. - Until integration, the component stays the app's; nothing becomes Core automatically. - Local components use feature names (c-affiliate-*), never Core names; the app checks still apply. - Design route: designer proposes from Custom components → Core decides and builds → release. Example: Profile header. - Corrections and Core work: a reviewed PR in the Plectrum repo. Source: Contribute — https://solidaris-danielbodigil.github.io/solidaris-plectrum/storybook/latest/?path=/docs/get-started-contribute--docs</a:t>
+              <a:t>KEY MESSAGE: two routes to Core — from an app team or from the design team. - Propose early: Core can spot duplicates and give guidance on reuse, naming and tokens — and the team never waits to build locally. - Ask /plectrum first: it checks reuse and helps with layout and UX; designers still join the loop early for new UX. - Step 1 in practice: npm run pds:component lists similar components other teams already built; the team fills the Reuse potential line; CI reports the component to Core. Core contacts the team when a component is worth sharing. - Colours = actor: green app, blue Core, orange designer, grey release. - Every proposal is a GitHub issue in the central Plectrum repo — from an app team or a designer. - App route: the team builds in its repo → proposes the component → Core decides → the team submits (candidate-submit) → Core integrates → designer updates Figma → release → the app adopts. - Until integration, the component stays the app's; nothing becomes Core automatically. - Local components use feature names (c-affiliate-*), never Core names; the app checks still apply. - Design route: designer proposes from Custom components → Core decides and builds → release. Example: Profile header. - Corrections and Core work: a reviewed PR in the Plectrum repo. Source: Contribute — https://solidaris-danielbodigil.github.io/solidaris-plectrum/storybook/latest/?path=/docs/get-started-contribute--docs</a:t>
             </a:r>
             <a:endParaRPr lang="en-US" dirty="0"/>
           </a:p>
@@ -1045,7 +1045,7 @@
           <a:p>
             <a:r>
               <a:rPr lang="en-US" dirty="0"/>
-              <a:t>KEY MESSAGE: the whole process exists to stop teams redoing the same work — and everyone gains something. - Less duplicate maintenance (Core, app teams): one source, generated docs, no design-system code copied into apps. - Fewer local variants (app teams, Solidaris): PrimeNG → Core → local build → proposal; one look across applications. - Earlier feedback (app teams, designers): stories, CI and review catch issues in the PR; sync results land in Figma. - Repeatable adoption (Solidaris, new teams): a new team = the starter + npm install; upgrades arrive as PRs; usage reports show who uses what. - Ask of every team: consume the packages, run the checks, return shared improvements through a GitHub issue. - Next step: one real pilot team walks the full path — local build → proposal → decision → submission → integration → release → adoption. Source: Overview — https://solidaris-danielbodigil.github.io/solidaris-plectrum/storybook/latest/?path=/docs/introduction--docs</a:t>
+              <a:t>KEY MESSAGE: the whole process exists to stop teams redoing the same work — and everyone gains something. - Less duplicate maintenance (Core, app teams): one source, generated docs, no design-system code copied into apps. - Fewer local variants (app teams, Solidaris): PrimeNG → Core → local build; local components are reported to Core, scaffold warns about similar ones from other teams, and Core picks what to share. - Earlier feedback (app teams, designers): stories, CI and review catch issues in the PR; sync results land in Figma. - Repeatable adoption (Solidaris, new teams): a new team = the starter + npm install; upgrades arrive as PRs; usage reports show who uses what. - Ask of every team: consume the packages, run the checks, return shared improvements through a GitHub issue. - Next step: one real pilot team walks the full path — local build → proposal → decision → submission → integration → release → adoption. Source: Overview — https://solidaris-danielbodigil.github.io/solidaris-plectrum/storybook/latest/?path=/docs/introduction--docs</a:t>
             </a:r>
             <a:endParaRPr lang="en-US" dirty="0"/>
           </a:p>
@@ -1309,7 +1309,7 @@
           <a:p>
             <a:r>
               <a:rPr lang="en-US" dirty="0"/>
-              <a:t>KEY MESSAGE: teams don't copy Plectrum — they install it as versioned packages and keep their own repo. - 4 packages under @solidaris-danielbodigil on GitHub Packages (private; the team needs read access). - Runtime: pds-ui, pds-plectrum, pds-styles (styles, tokens, Agenda and Open Sans fonts) — version together. Toolkit: pds-devkit — dev dependency, own version. - Install: copy the Plectrum starter, set the team and application IDs in package.json, run npm install. - Set up: npm install runs plectrum bootstrap — empty local ITCSS layers, styles and fonts wired, local Storybook, unit and story tests, a pre-commit hook, agents and a CI workflow. Commit the generated files. - Build: providePlectrum() is already in app.config; local styles go in src/styles/06-components. - Validate: the generated workflow runs the checks, the build, unit tests and story + accessibility tests on every PR. - Adopt: CI sends a usage report to Core once the team is registered and the PLECTRUM_ADOPTION_TOKEN secret is set; the local Storybook page Plectrum/Setup shows what is missing. - Upgrade: Renovate / Dependabot PRs → plectrum update → checks. What's new lists the changes. Source: Build with Plectrum — https://solidaris-danielbodigil.github.io/solidaris-plectrum/storybook/latest/?path=/docs/get-started-use-plectrum-in-an-app--docs</a:t>
+              <a:t>KEY MESSAGE: teams don't copy Plectrum — they install it as versioned packages and keep their own repo. - 4 packages under @solidaris-danielbodigil on GitHub Packages (private; the team needs read access). - Runtime: pds-ui, pds-plectrum, pds-styles (styles, tokens, Agenda and Open Sans fonts) — version together. Toolkit: pds-devkit — dev dependency, own version. - Install: copy the Plectrum starter, set the team and application IDs in package.json, run npm install. - Set up: npm install runs plectrum bootstrap — empty local ITCSS layers, styles and fonts wired, local Storybook, unit and story tests, a pre-commit hook, agents and a CI workflow. Commit the generated files. - Build: providePlectrum() is already in app.config; local styles go in src/styles/06-components. - Validate: the generated workflow runs the checks, the build, unit tests and story + accessibility tests on every PR. - Adopt: CI sends a usage report to Core — the Plectrum components the app uses and the team's local components with their reuse estimate — once the team is registered and the PLECTRUM_ADOPTION_TOKEN secret is set; the local Storybook page Plectrum/Setup shows what is missing. - Upgrade: Renovate / Dependabot PRs → plectrum update → checks. What's new lists the changes. Source: Build with Plectrum — https://solidaris-danielbodigil.github.io/solidaris-plectrum/storybook/latest/?path=/docs/get-started-use-plectrum-in-an-app--docs</a:t>
             </a:r>
             <a:endParaRPr lang="en-US" dirty="0"/>
           </a:p>
@@ -7705,7 +7705,7 @@
                 <a:ea typeface="Nunito Sans" pitchFamily="34" charset="-122"/>
                 <a:cs typeface="Nunito Sans" pitchFamily="34" charset="-120"/>
               </a:rPr>
-              <a:t>your team builds and owns it</a:t>
+              <a:t>your team builds it, then submits it</a:t>
             </a:r>
             <a:endParaRPr lang="en-US" sz="1196" dirty="0"/>
           </a:p>
@@ -11241,7 +11241,7 @@
                 <a:ea typeface="Nunito Sans" pitchFamily="34" charset="-122"/>
                 <a:cs typeface="Nunito Sans" pitchFamily="34" charset="-120"/>
               </a:rPr>
-              <a:t>reuse + contracts</a:t>
+              <a:t>reuse + local components seen by Core</a:t>
             </a:r>
             <a:endParaRPr lang="en-US" sz="1200" dirty="0"/>
           </a:p>
@@ -14453,7 +14453,7 @@
                 <a:ea typeface="Nunito Sans" pitchFamily="34" charset="-122"/>
                 <a:cs typeface="Nunito Sans" pitchFamily="34" charset="-120"/>
               </a:rPr>
-              <a:t> — CI reports component usage to Core</a:t>
+              <a:t> — CI reports usage and local components</a:t>
             </a:r>
             <a:endParaRPr lang="en-US" sz="1300" dirty="0"/>
           </a:p>

</xml_diff>

<commit_message>
feat: drop the "rejected" proposal decision
Teams own their components, so a proposal is never refused: Core
answers approved-candidate, use-existing or app-specific. The proposal
schema, process contract and generated rules lose "rejected"; a
submitted candidate that Core does not integrate becomes "kept-local"
("Kept local" in Find a component). Docs and the deck (slide 13 now
shows three decisions; notes updated) follow.

Co-Authored-By: Claude Opus 5.5 <noreply@anthropic.com>
</commit_message>
<xml_diff>
--- a/docs/Storybook for application teams.pptx
+++ b/docs/Storybook for application teams.pptx
@@ -869,7 +869,7 @@
           <a:p>
             <a:r>
               <a:rPr lang="en-US" dirty="0"/>
-              <a:t>KEY MESSAGE: build locally; propose to share. - Small fix (typo, example, link): PR on Plectrum. - Gap (component, variant, token): check themed PrimeNG and Core first; if nothing fits, the team builds it in its own repo — no approval needed. - To share it, open a proposal = a GitHub issue on Plectrum: the need, what you tried, a Figma link, a preview. - Core records one decision: use-existing · app-specific · rejected · approved-candidate. - Only approved-candidate lets the team submit the component to Core; the other decisions keep it local. - Your team builds it → your team owns it. Nothing becomes Core automatically. - Before building, ask /plectrum: it often finds that an existing component or composition already does the job. For new UX, talk early to the core team or a designer — advice, not an approval step. - Teams do not have to spot what is worth sharing: each local component's evidence checklist has a Reuse potential line (none / possible / likely), the usage report sends it to Core, and Core reviews the Local scope of Find a component to pick what to share. Source: Contribute › Proposal decisions — https://solidaris-danielbodigil.github.io/solidaris-plectrum/storybook/latest/?path=/docs/get-started-contribute--docs</a:t>
+              <a:t>KEY MESSAGE: build locally; propose to share. - Small fix (typo, example, link): PR on Plectrum. - Gap (component, variant, token): check themed PrimeNG and Core first; if nothing fits, the team builds it in its own repo — no approval needed. - To share it, open a proposal = a GitHub issue on Plectrum: the need, what you tried, a Figma link, a preview. - Core records one of three decisions: use-existing · app-specific · approved-candidate. There is no rejection — the team owns its component and can always keep it locally. - Only approved-candidate lets the team submit the component to Core; the other two keep it in the application. - Your team builds it → your team owns it. Nothing becomes Core automatically. - Before building, ask /plectrum: it often finds that an existing component or composition already does the job. For new UX, talk early to the core team or a designer — advice, not an approval step. - Teams do not have to spot what is worth sharing: each local component's evidence checklist has a Reuse potential line (none / possible / likely), the usage report sends it to Core, and Core reviews the Local scope of Find a component to pick what to share. Source: Contribute › Proposal decisions — https://solidaris-danielbodigil.github.io/solidaris-plectrum/storybook/latest/?path=/docs/get-started-contribute--docs</a:t>
             </a:r>
             <a:endParaRPr lang="en-US" dirty="0"/>
           </a:p>
@@ -7483,128 +7483,13 @@
       </p:sp>
       <p:sp>
         <p:nvSpPr>
-          <p:cNvPr id="22" name="Shape 20"/>
-          <p:cNvSpPr/>
-          <p:nvPr/>
-        </p:nvSpPr>
-        <p:spPr>
-          <a:xfrm>
-            <a:off x="8210550" y="4397871"/>
-            <a:ext cx="3162300" cy="546100"/>
-          </a:xfrm>
-          <a:prstGeom prst="roundRect">
-            <a:avLst>
-              <a:gd name="adj" fmla="val 15116"/>
-            </a:avLst>
-          </a:prstGeom>
-          <a:solidFill>
-            <a:srgbClr val="FFFFFF"/>
-          </a:solidFill>
-          <a:ln w="12700">
-            <a:solidFill>
-              <a:srgbClr val="7A838C"/>
-            </a:solidFill>
-            <a:prstDash val="solid"/>
-          </a:ln>
-        </p:spPr>
-      </p:sp>
-      <p:sp>
-        <p:nvSpPr>
-          <p:cNvPr id="23" name="Text 21"/>
-          <p:cNvSpPr/>
-          <p:nvPr/>
-        </p:nvSpPr>
-        <p:spPr>
-          <a:xfrm>
-            <a:off x="8343900" y="4457601"/>
-            <a:ext cx="2982468" cy="238720"/>
-          </a:xfrm>
-          <a:prstGeom prst="rect">
-            <a:avLst/>
-          </a:prstGeom>
-          <a:noFill/>
-          <a:ln/>
-        </p:spPr>
-        <p:txBody>
-          <a:bodyPr wrap="square" lIns="0" tIns="0" rIns="0" bIns="0" rtlCol="0" anchor="t">
-            <a:normAutofit/>
-          </a:bodyPr>
-          <a:lstStyle/>
-          <a:p>
-            <a:pPr algn="l" indent="0" marL="0">
-              <a:lnSpc>
-                <a:spcPts val="1680"/>
-              </a:lnSpc>
-              <a:buNone/>
-            </a:pPr>
-            <a:r>
-              <a:rPr lang="en-US" sz="1200" b="1" dirty="0">
-                <a:solidFill>
-                  <a:srgbClr val="4A535B"/>
-                </a:solidFill>
-                <a:latin typeface="JetBrains Mono" pitchFamily="34" charset="0"/>
-                <a:ea typeface="JetBrains Mono" pitchFamily="34" charset="-122"/>
-                <a:cs typeface="JetBrains Mono" pitchFamily="34" charset="-120"/>
-              </a:rPr>
-              <a:t>rejected</a:t>
-            </a:r>
-            <a:endParaRPr lang="en-US" sz="1200" dirty="0"/>
-          </a:p>
-        </p:txBody>
-      </p:sp>
-      <p:sp>
-        <p:nvSpPr>
-          <p:cNvPr id="24" name="Text 22"/>
-          <p:cNvSpPr/>
-          <p:nvPr/>
-        </p:nvSpPr>
-        <p:spPr>
-          <a:xfrm>
-            <a:off x="8343900" y="4670921"/>
-            <a:ext cx="2982468" cy="238720"/>
-          </a:xfrm>
-          <a:prstGeom prst="rect">
-            <a:avLst/>
-          </a:prstGeom>
-          <a:noFill/>
-          <a:ln/>
-        </p:spPr>
-        <p:txBody>
-          <a:bodyPr wrap="square" lIns="0" tIns="0" rIns="0" bIns="0" rtlCol="0" anchor="t">
-            <a:normAutofit/>
-          </a:bodyPr>
-          <a:lstStyle/>
-          <a:p>
-            <a:pPr algn="l" indent="0" marL="0">
-              <a:lnSpc>
-                <a:spcPts val="1680"/>
-              </a:lnSpc>
-              <a:buNone/>
-            </a:pPr>
-            <a:r>
-              <a:rPr lang="en-US" sz="1200" dirty="0">
-                <a:solidFill>
-                  <a:srgbClr val="55555C"/>
-                </a:solidFill>
-                <a:latin typeface="Nunito Sans" pitchFamily="34" charset="0"/>
-                <a:ea typeface="Nunito Sans" pitchFamily="34" charset="-122"/>
-                <a:cs typeface="Nunito Sans" pitchFamily="34" charset="-120"/>
-              </a:rPr>
-              <a:t>not shared; build locally if needed</a:t>
-            </a:r>
-            <a:endParaRPr lang="en-US" sz="1200" dirty="0"/>
-          </a:p>
-        </p:txBody>
-      </p:sp>
-      <p:sp>
-        <p:nvSpPr>
           <p:cNvPr id="25" name="Shape 23"/>
           <p:cNvSpPr/>
           <p:nvPr/>
         </p:nvSpPr>
         <p:spPr>
           <a:xfrm>
-            <a:off x="8213725" y="5112246"/>
+            <a:off x="8213725" y="4397871"/>
             <a:ext cx="3155950" cy="539750"/>
           </a:xfrm>
           <a:prstGeom prst="roundRect">
@@ -7631,7 +7516,7 @@
         </p:nvSpPr>
         <p:spPr>
           <a:xfrm>
-            <a:off x="8350250" y="5172571"/>
+            <a:off x="8350250" y="4458196"/>
             <a:ext cx="2969387" cy="234950"/>
           </a:xfrm>
           <a:prstGeom prst="rect">
@@ -7675,7 +7560,7 @@
         </p:nvSpPr>
         <p:spPr>
           <a:xfrm>
-            <a:off x="8350250" y="5382121"/>
+            <a:off x="8350250" y="4667746"/>
             <a:ext cx="2969387" cy="234950"/>
           </a:xfrm>
           <a:prstGeom prst="rect">
@@ -7888,7 +7773,7 @@
         <p:spPr>
           <a:xfrm>
             <a:off x="8013700" y="3197721"/>
-            <a:ext cx="101600" cy="2235200"/>
+            <a:ext cx="101600" cy="1524000"/>
           </a:xfrm>
           <a:prstGeom prst="rect">
             <a:avLst/>
@@ -7943,29 +7828,6 @@
       </p:pic>
       <p:pic>
         <p:nvPicPr>
-          <p:cNvPr id="38" name="Image 10" descr="connector">    </p:cNvPr>
-          <p:cNvPicPr>
-            <a:picLocks noChangeAspect="1"/>
-          </p:cNvPicPr>
-          <p:nvPr/>
-        </p:nvPicPr>
-        <p:blipFill>
-          <a:blip r:embed="rId11"/>
-          <a:srcRect l="0" r="0" t="0" b="0"/>
-          <a:stretch/>
-        </p:blipFill>
-        <p:spPr>
-          <a:xfrm>
-            <a:off x="8013700" y="4620121"/>
-            <a:ext cx="241300" cy="101600"/>
-          </a:xfrm>
-          <a:prstGeom prst="rect">
-            <a:avLst/>
-          </a:prstGeom>
-        </p:spPr>
-      </p:pic>
-      <p:pic>
-        <p:nvPicPr>
           <p:cNvPr id="39" name="Image 11" descr="connector">    </p:cNvPr>
           <p:cNvPicPr>
             <a:picLocks noChangeAspect="1"/>
@@ -7979,7 +7841,7 @@
         </p:blipFill>
         <p:spPr>
           <a:xfrm>
-            <a:off x="8013700" y="5331321"/>
+            <a:off x="8013700" y="4620121"/>
             <a:ext cx="241300" cy="101600"/>
           </a:xfrm>
           <a:prstGeom prst="rect">

</xml_diff>

<commit_message>
docs: present the agent as recommended, not optional, in the deck
Slide 9 reads "AI-first — recommended, not required" and notes 1 and 9
say why: the agent answers most reuse, layout and UX questions without
waiting for Core, while working by hand stays possible.

Co-Authored-By: Claude Opus 5.5 <noreply@anthropic.com>
(cherry picked from commit 7d926be945a118133a0406a27bf0694e8371d70d)
</commit_message>
<xml_diff>
--- a/docs/Storybook for application teams.pptx
+++ b/docs/Storybook for application teams.pptx
@@ -517,7 +517,7 @@
           <a:p>
             <a:r>
               <a:rPr lang="en-US" dirty="0"/>
-              <a:t>KEY MESSAGE: Storybook is the entry point to Plectrum — what exists, how to use it, what state it is in. - Goal: everyone leaves knowing where to find a component, how to start, where to report a gap. - Overview only: no terminal, no live demo; details stay in Storybook. - For every application team: iShare, iCRM, iGED and every team that joins later. - Flow: structure · SSOTs · token pipelines · AI-first (optional) · CI · PRs · contributing · scale · benefits. - About 25 min + questions. - Transition: "First, where Storybook sits in Plectrum." Source: Overview — https://solidaris-danielbodigil.github.io/solidaris-plectrum/storybook/?path=/docs/introduction--docs</a:t>
+              <a:t>KEY MESSAGE: Storybook is the entry point to Plectrum — what exists, how to use it, what state it is in. - Goal: everyone leaves knowing where to find a component, how to start, where to report a gap. - Overview only: no terminal, no live demo; details stay in Storybook. - For every application team: iShare, iCRM, iGED and every team that joins later. - Flow: structure · SSOTs · token pipelines · AI-first (recommended) · CI · PRs · contributing · scale · benefits. - About 25 min + questions. - Transition: "First, where Storybook sits in Plectrum." Source: Overview — https://solidaris-danielbodigil.github.io/solidaris-plectrum/storybook/?path=/docs/introduction--docs</a:t>
             </a:r>
             <a:endParaRPr lang="en-US" dirty="0"/>
           </a:p>
@@ -1837,7 +1837,7 @@
           <a:p>
             <a:r>
               <a:rPr lang="en-US" dirty="0"/>
-              <a:t>KEY MESSAGE: no AI? Nothing lost — same scripts, same CI, same reviews. - Find — agent: PrimeNG MCP → index.json → Storybook MCP (same order as the pre-flight on slide 7). - Find — by hand: themed PrimeNG first, then Find a component or plectrum catalogue (offline). - Create: npm run pds:component in an app (no approval needed), pds:component in the Plectrum repo. - Check: npm run pds:check:ci, then build and tests. - Figma to tokens: an agent reads variables via Figma MCP, or the designer runs the plugin sync; the CI drift audit runs and a developer merges the PR. - Tokens to Figma: tokens:propose + the Plectrum tokens plugin. - Figma components: a designer draws them; merge and publish stay human. - CI runs regardless — agent and human changes alike. Source: AI strategy · Token pipeline › Commands — https://solidaris-danielbodigil.github.io/solidaris-plectrum/storybook/latest/?path=/docs/docs-ai-strategy--docs</a:t>
+              <a:t>KEY MESSAGE: the agent is recommended — it answers most reuse, layout and UX questions without waiting for Core — but working by hand stays possible: same scripts, same CI, same reviews. - Find — agent: PrimeNG MCP → index.json → Storybook MCP (same order as the pre-flight on slide 7). - Find — by hand: themed PrimeNG first, then Find a component or plectrum catalogue (offline). - Create: npm run pds:component in an app (no approval needed), pds:component in the Plectrum repo. - Check: npm run pds:check:ci, then build and tests. - Figma to tokens: an agent reads variables via Figma MCP, or the designer runs the plugin sync; the CI drift audit runs and a developer merges the PR. - Tokens to Figma: tokens:propose + the Plectrum tokens plugin. - Figma components: a designer draws them; merge and publish stay human. - CI runs regardless — agent and human changes alike. Source: AI strategy · Token pipeline › Commands — https://solidaris-danielbodigil.github.io/solidaris-plectrum/storybook/latest/?path=/docs/docs-ai-strategy--docs</a:t>
             </a:r>
             <a:endParaRPr lang="en-US" dirty="0"/>
           </a:p>
@@ -21301,7 +21301,7 @@
                 <a:ea typeface="Alegreya Sans" pitchFamily="34" charset="-122"/>
                 <a:cs typeface="Alegreya Sans" pitchFamily="34" charset="-120"/>
               </a:rPr>
-              <a:t>AI-FIRST — OPTIONAL</a:t>
+              <a:t>AI-FIRST — RECOMMENDED, NOT REQUIRED</a:t>
             </a:r>
             <a:endParaRPr lang="en-US" sz="1300" dirty="0"/>
           </a:p>

</xml_diff>

<commit_message>
feat(ui): hide Figma references in Find a token
Add a showFigmaRefs input to the token explorer and turn it off in the
token finder, where the references are still incomplete. Refresh the
application teams deck.

Co-Authored-By: Claude Opus 5.5 <noreply@anthropic.com>
</commit_message>
<xml_diff>
--- a/docs/Storybook for application teams.pptx
+++ b/docs/Storybook for application teams.pptx
@@ -16763,7 +16763,7 @@
         </p:spPr>
         <p:txBody>
           <a:bodyPr wrap="square" lIns="0" tIns="0" rIns="0" bIns="0" rtlCol="0" anchor="t">
-            <a:normAutofit/>
+            <a:normAutofit fontScale="92500" lnSpcReduction="10000"/>
           </a:bodyPr>
           <a:lstStyle/>
           <a:p>
@@ -17134,7 +17134,7 @@
         </p:nvGraphicFramePr>
         <p:xfrm>
           <a:off x="825500" y="1762621"/>
-          <a:ext cx="10553700" cy="2328069"/>
+          <a:ext cx="10553700" cy="2328067"/>
         </p:xfrm>
         <a:graphic>
           <a:graphicData uri="http://schemas.openxmlformats.org/drawingml/2006/table">
@@ -22780,7 +22780,7 @@
         </p:nvGraphicFramePr>
         <p:xfrm>
           <a:off x="825500" y="1686421"/>
-          <a:ext cx="10553700" cy="2514898"/>
+          <a:ext cx="10553700" cy="2514897"/>
         </p:xfrm>
         <a:graphic>
           <a:graphicData uri="http://schemas.openxmlformats.org/drawingml/2006/table">

</xml_diff>